<commit_message>
Rebuild predictor with current 2026 apartment data
</commit_message>
<xml_diff>
--- a/presentation/Tashkent_House_Price_Defense.pptx
+++ b/presentation/Tashkent_House_Price_Defense.pptx
@@ -3457,13 +3457,13 @@
           <a:p>
             <a:pPr algn="l"/>
             <a:r>
-              <a:rPr sz="4300" b="1">
+              <a:rPr sz="3900" b="1">
                 <a:solidFill>
                   <a:srgbClr val="0D5BFF"/>
                 </a:solidFill>
                 <a:latin typeface="Aptos"/>
               </a:rPr>
-              <a:t>HOUSE PRICE</a:t>
+              <a:t>APARTMENT PRICE</a:t>
             </a:r>
           </a:p>
         </p:txBody>
@@ -3648,7 +3648,7 @@
                 </a:solidFill>
                 <a:latin typeface="Aptos"/>
               </a:rPr>
-              <a:t>Estimate a historical 2019 Tashkent apartment asking price from observable listing attributes.</a:t>
+              <a:t>Estimate a current August 2026 Tashkent apartment asking price from observable listing attributes.</a:t>
             </a:r>
           </a:p>
         </p:txBody>
@@ -3763,7 +3763,7 @@
                 </a:solidFill>
                 <a:latin typeface="Aptos"/>
               </a:rPr>
-              <a:t>6,725</a:t>
+              <a:t>4,214</a:t>
             </a:r>
           </a:p>
         </p:txBody>
@@ -3798,7 +3798,7 @@
                 </a:solidFill>
                 <a:latin typeface="Aptos"/>
               </a:rPr>
-              <a:t>DE-DUPLICATED ROWS</a:t>
+              <a:t>MODELING ROWS</a:t>
             </a:r>
           </a:p>
         </p:txBody>
@@ -3993,7 +3993,7 @@
                 </a:solidFill>
                 <a:latin typeface="Aptos"/>
               </a:rPr>
-              <a:t>0.745</a:t>
+              <a:t>0.681</a:t>
             </a:r>
           </a:p>
         </p:txBody>
@@ -4108,7 +4108,7 @@
                 </a:solidFill>
                 <a:latin typeface="Aptos"/>
               </a:rPr>
-              <a:t>$10,573</a:t>
+              <a:t>$27,195</a:t>
             </a:r>
           </a:p>
         </p:txBody>
@@ -4690,7 +4690,7 @@
                 </a:solidFill>
                 <a:latin typeface="Aptos"/>
               </a:rPr>
-              <a:t>Lowest CV MAE ($11,108).
+              <a:t>Lowest group-safe CV MAE ($31,298).
 Open reports/model_comparison.csv.
 Trade-off: size and interpretability.</a:t>
             </a:r>
@@ -4850,9 +4850,9 @@
                 </a:solidFill>
                 <a:latin typeface="Aptos"/>
               </a:rPr>
-              <a:t>No — 2019 asking-price estimate.
-Open README limitations.
-Next: current transaction data + time split.</a:t>
+              <a:t>Yes — dated Aug 2026 asking-price snapshot.
+Open data/README.md.
+Not a permanently live or completed-sale model.</a:t>
             </a:r>
           </a:p>
         </p:txBody>
@@ -5010,7 +5010,7 @@
                 </a:solidFill>
                 <a:latin typeface="Aptos"/>
               </a:rPr>
-              <a:t>$800k Mirobod actual vs ~$355k predicted.
+              <a:t>$1m Shayhontohur actual vs ~$234k predicted.
 Open largest_errors.csv.
 Missing luxury/condition signal.</a:t>
             </a:r>
@@ -5639,7 +5639,7 @@
                 </a:solidFill>
                 <a:latin typeface="Aptos"/>
               </a:rPr>
-              <a:t>Buyers, sellers, agents, and analysts who need a consistent historical reference estimate.</a:t>
+              <a:t>Buyers, sellers, agents, and analysts who need a consistent August 2026 reference estimate.</a:t>
             </a:r>
           </a:p>
         </p:txBody>
@@ -5797,8 +5797,8 @@
                 </a:solidFill>
                 <a:latin typeface="Aptos"/>
               </a:rPr>
-              <a:t>Inputs: district, size, rooms, apartment level, building levels, latitude, longitude.
-Target: listing price.</a:t>
+              <a:t>Inputs: district, size, rooms, apartment level, building levels, new-build/resale.
+Target: asking price.</a:t>
             </a:r>
           </a:p>
         </p:txBody>
@@ -5956,8 +5956,8 @@
                 </a:solidFill>
                 <a:latin typeface="Aptos"/>
               </a:rPr>
-              <a:t>One estimated 2019 asking price in USD, plus warnings.
-Not a current quote, sale guarantee, or legal appraisal.</a:t>
+              <a:t>One estimated August 2026 asking price in USD, plus warnings.
+Not a completed sale price, guarantee, or legal appraisal.</a:t>
             </a:r>
           </a:p>
         </p:txBody>
@@ -6391,7 +6391,7 @@
                 </a:solidFill>
                 <a:latin typeface="Aptos"/>
               </a:rPr>
-              <a:t>FROM 7,421 LISTINGS TO A LEAKAGE-SAFE TEST</a:t>
+              <a:t>FROM 4,867 LISTINGS TO A GROUP-SAFE TEST</a:t>
             </a:r>
           </a:p>
         </p:txBody>
@@ -6426,7 +6426,7 @@
                 </a:solidFill>
                 <a:latin typeface="Aptos"/>
               </a:rPr>
-              <a:t>CC0 uybor.uz advertisements collected in Tashkent in 2019.</a:t>
+              <a:t>Privacy-minimized public HATA snapshot collected 22 August 2026.</a:t>
             </a:r>
           </a:p>
         </p:txBody>
@@ -6584,8 +6584,8 @@
                 </a:solidFill>
                 <a:latin typeface="Aptos"/>
               </a:rPr>
-              <a:t>7,421 rows
-9 columns</a:t>
+              <a:t>4,867 parsed
+11 districts</a:t>
             </a:r>
           </a:p>
         </p:txBody>
@@ -6778,7 +6778,7 @@
                 </a:solidFill>
                 <a:latin typeface="Aptos"/>
               </a:rPr>
-              <a:t>696 exact
+              <a:t>257 invalid + 396
 duplicates removed</a:t>
             </a:r>
           </a:p>
@@ -6972,8 +6972,8 @@
                 </a:solidFill>
                 <a:latin typeface="Aptos"/>
               </a:rPr>
-              <a:t>80% develop
-20% protected test</a:t>
+              <a:t>3,840 groups
+80% / 20%</a:t>
             </a:r>
           </a:p>
         </p:txBody>
@@ -7167,7 +7167,7 @@
                 <a:latin typeface="Aptos"/>
               </a:rPr>
               <a:t>5-fold CV
-stratified by district</a:t>
+group-safe</a:t>
             </a:r>
           </a:p>
         </p:txBody>
@@ -7360,8 +7360,8 @@
                 </a:solidFill>
                 <a:latin typeface="Aptos"/>
               </a:rPr>
-              <a:t>1,345 unseen
-test rows</a:t>
+              <a:t>835 unseen rows
+768 groups</a:t>
             </a:r>
           </a:p>
         </p:txBody>
@@ -7476,7 +7476,7 @@
                 </a:solidFill>
                 <a:latin typeface="Aptos"/>
               </a:rPr>
-              <a:t>duplicate removal before split  •  no target-derived features  •  encoding/scaling inside each sklearn pipeline  •  test not used for selection</a:t>
+              <a:t>feature+target deduplication  •  identical fingerprints grouped  •  no price/m² leakage  •  preprocessing inside CV  •  test not used for selection</a:t>
             </a:r>
           </a:p>
         </p:txBody>
@@ -8025,7 +8025,7 @@
                           </a:solidFill>
                           <a:latin typeface="Aptos"/>
                         </a:rPr>
-                        <a:t>$25,220</a:t>
+                        <a:t>$55,604</a:t>
                       </a:r>
                     </a:p>
                   </a:txBody>
@@ -8048,7 +8048,7 @@
                           </a:solidFill>
                           <a:latin typeface="Aptos"/>
                         </a:rPr>
-                        <a:t>$47,276</a:t>
+                        <a:t>$123,587</a:t>
                       </a:r>
                     </a:p>
                   </a:txBody>
@@ -8071,7 +8071,7 @@
                           </a:solidFill>
                           <a:latin typeface="Aptos"/>
                         </a:rPr>
-                        <a:t>-0.081</a:t>
+                        <a:t>-0.068</a:t>
                       </a:r>
                     </a:p>
                   </a:txBody>
@@ -8119,7 +8119,7 @@
                           </a:solidFill>
                           <a:latin typeface="Aptos"/>
                         </a:rPr>
-                        <a:t>$15,580</a:t>
+                        <a:t>$38,301</a:t>
                       </a:r>
                     </a:p>
                   </a:txBody>
@@ -8142,7 +8142,7 @@
                           </a:solidFill>
                           <a:latin typeface="Aptos"/>
                         </a:rPr>
-                        <a:t>$47,449</a:t>
+                        <a:t>$105,755</a:t>
                       </a:r>
                     </a:p>
                   </a:txBody>
@@ -8165,7 +8165,7 @@
                           </a:solidFill>
                           <a:latin typeface="Aptos"/>
                         </a:rPr>
-                        <a:t>-0.248</a:t>
+                        <a:t>0.219</a:t>
                       </a:r>
                     </a:p>
                   </a:txBody>
@@ -8213,7 +8213,7 @@
                           </a:solidFill>
                           <a:latin typeface="Aptos"/>
                         </a:rPr>
-                        <a:t>$11,108</a:t>
+                        <a:t>$31,298</a:t>
                       </a:r>
                     </a:p>
                   </a:txBody>
@@ -8236,7 +8236,7 @@
                           </a:solidFill>
                           <a:latin typeface="Aptos"/>
                         </a:rPr>
-                        <a:t>$23,289</a:t>
+                        <a:t>$80,394</a:t>
                       </a:r>
                     </a:p>
                   </a:txBody>
@@ -8259,7 +8259,7 @@
                           </a:solidFill>
                           <a:latin typeface="Aptos"/>
                         </a:rPr>
-                        <a:t>0.736</a:t>
+                        <a:t>0.556</a:t>
                       </a:r>
                     </a:p>
                   </a:txBody>
@@ -8307,7 +8307,7 @@
                           </a:solidFill>
                           <a:latin typeface="Aptos"/>
                         </a:rPr>
-                        <a:t>$12,099</a:t>
+                        <a:t>$33,545</a:t>
                       </a:r>
                     </a:p>
                   </a:txBody>
@@ -8330,7 +8330,7 @@
                           </a:solidFill>
                           <a:latin typeface="Aptos"/>
                         </a:rPr>
-                        <a:t>$25,473</a:t>
+                        <a:t>$94,081</a:t>
                       </a:r>
                     </a:p>
                   </a:txBody>
@@ -8353,7 +8353,7 @@
                           </a:solidFill>
                           <a:latin typeface="Aptos"/>
                         </a:rPr>
-                        <a:t>0.685</a:t>
+                        <a:t>0.396</a:t>
                       </a:r>
                     </a:p>
                   </a:txBody>
@@ -8992,7 +8992,7 @@
                 </a:solidFill>
                 <a:latin typeface="Aptos"/>
               </a:rPr>
-              <a:t>$10,573</a:t>
+              <a:t>$27,195</a:t>
             </a:r>
           </a:p>
         </p:txBody>
@@ -9107,7 +9107,7 @@
                 </a:solidFill>
                 <a:latin typeface="Aptos"/>
               </a:rPr>
-              <a:t>$23,162</a:t>
+              <a:t>$58,887</a:t>
             </a:r>
           </a:p>
         </p:txBody>
@@ -9222,7 +9222,7 @@
                 </a:solidFill>
                 <a:latin typeface="Aptos"/>
               </a:rPr>
-              <a:t>0.745</a:t>
+              <a:t>0.681</a:t>
             </a:r>
           </a:p>
         </p:txBody>
@@ -9337,7 +9337,7 @@
                 </a:solidFill>
                 <a:latin typeface="Aptos"/>
               </a:rPr>
-              <a:t>16.66%</a:t>
+              <a:t>24.58%</a:t>
             </a:r>
           </a:p>
         </p:txBody>
@@ -9452,7 +9452,7 @@
                 </a:solidFill>
                 <a:latin typeface="Aptos"/>
               </a:rPr>
-              <a:t>−56.3%</a:t>
+              <a:t>−46.6%</a:t>
             </a:r>
           </a:p>
         </p:txBody>
@@ -9645,9 +9645,9 @@
                 </a:solidFill>
                 <a:latin typeface="Aptos"/>
               </a:rPr>
-              <a:t>Mirobod • 456 m² • 10 rooms
-Actual: $800,000   Predicted: $354,962
-Absolute error: $445,038</a:t>
+              <a:t>Shayhontohur • 160 m² • 3 rooms • new build
+Actual: $1,000,000   Predicted: $234,461
+Absolute error: $765,539</a:t>
             </a:r>
           </a:p>
         </p:txBody>
@@ -9805,7 +9805,7 @@
                 </a:solidFill>
                 <a:latin typeface="Aptos"/>
               </a:rPr>
-              <a:t>Luxury premiums and condition are not fully observed. Bektemir and Yangihayot are too sparse for reliable slice claims.</a:t>
+              <a:t>Luxury premiums and condition are not observed. Mirobod and Shayhontohur MAE is high; some district slice R² values are negative.</a:t>
             </a:r>
           </a:p>
         </p:txBody>
@@ -10309,11 +10309,11 @@
                 </a:solidFill>
                 <a:latin typeface="Aptos"/>
               </a:rPr>
-              <a:t>District     Chilonzor
-Size         70 m²
-Rooms        3
-Level        3 / 5
-Coordinates  41.3002, 69.2108</a:t>
+              <a:t>District      Chilonzor
+Size          70 m²
+Rooms         3
+Level         3 / 5
+Building type Resale</a:t>
             </a:r>
           </a:p>
         </p:txBody>
@@ -10428,7 +10428,7 @@
                 </a:solidFill>
                 <a:latin typeface="Aptos"/>
               </a:rPr>
-              <a:t>ESTIMATED 2019 ASKING PRICE</a:t>
+              <a:t>ESTIMATED AUGUST 2026 ASKING PRICE</a:t>
             </a:r>
           </a:p>
         </p:txBody>
@@ -10463,7 +10463,7 @@
                 </a:solidFill>
                 <a:latin typeface="Aptos"/>
               </a:rPr>
-              <a:t>$53,532 USD</a:t>
+              <a:t>$97,098 USD</a:t>
             </a:r>
           </a:p>
         </p:txBody>
@@ -11160,10 +11160,10 @@
                 </a:solidFill>
                 <a:latin typeface="Aptos"/>
               </a:rPr>
-              <a:t>2019 asking prices
-No condition / building age / legal status
-Sparse districts
-Location bias and market drift</a:t>
+              <a:t>Dated asking-price snapshot
+No condition / exact building / legal status
+Unequal district reliability
+Source noise and market drift</a:t>
             </a:r>
           </a:p>
         </p:txBody>
@@ -11321,7 +11321,7 @@
                 </a:solidFill>
                 <a:latin typeface="Aptos"/>
               </a:rPr>
-              <a:t>Historical reference only
+              <a:t>August 2026 reference only
 Compare with recent listings
 Require human review
 No lending, tax, or legal appraisal</a:t>
@@ -11482,7 +11482,7 @@
                 </a:solidFill>
                 <a:latin typeface="Aptos"/>
               </a:rPr>
-              <a:t>Collect current transaction data with date, condition, building year, renovation, and legal status; then use a time-aware holdout.</a:t>
+              <a:t>Collect verified transactions with exact neighborhood, condition, building year, renovation, and legal status; then use a later time holdout.</a:t>
             </a:r>
           </a:p>
         </p:txBody>
@@ -11951,7 +11951,7 @@
                 </a:solidFill>
                 <a:latin typeface="Aptos"/>
               </a:rPr>
-              <a:t>Open docs/evidence_matrix.md for the complete claim → location → why-proof mapping.</a:t>
+              <a:t>Open docs/capstone_evidence_matrix.md for the complete claim → location → why-proof mapping.</a:t>
             </a:r>
           </a:p>
         </p:txBody>
@@ -12133,7 +12133,7 @@
           </a:solidFill>
           <a:ln w="15240">
             <a:solidFill>
-              <a:srgbClr val="0D9D59"/>
+              <a:srgbClr val="E89D00"/>
             </a:solidFill>
           </a:ln>
         </p:spPr>
@@ -12174,7 +12174,7 @@
             <a:avLst/>
           </a:prstGeom>
           <a:solidFill>
-            <a:srgbClr val="0D9D59"/>
+            <a:srgbClr val="E89D00"/>
           </a:solidFill>
           <a:ln>
             <a:noFill/>
@@ -12228,7 +12228,7 @@
             <a:r>
               <a:rPr sz="1500" b="1">
                 <a:solidFill>
-                  <a:srgbClr val="0D9D59"/>
+                  <a:srgbClr val="E89D00"/>
                 </a:solidFill>
                 <a:latin typeface="Aptos"/>
               </a:rPr>
@@ -12765,7 +12765,7 @@
           </a:solidFill>
           <a:ln w="15240">
             <a:solidFill>
-              <a:srgbClr val="0D9D59"/>
+              <a:srgbClr val="E89D00"/>
             </a:solidFill>
           </a:ln>
         </p:spPr>
@@ -12806,7 +12806,7 @@
             <a:avLst/>
           </a:prstGeom>
           <a:solidFill>
-            <a:srgbClr val="0D9D59"/>
+            <a:srgbClr val="E89D00"/>
           </a:solidFill>
           <a:ln>
             <a:noFill/>
@@ -12860,7 +12860,7 @@
             <a:r>
               <a:rPr sz="1500" b="1">
                 <a:solidFill>
-                  <a:srgbClr val="0D9D59"/>
+                  <a:srgbClr val="E89D00"/>
                 </a:solidFill>
                 <a:latin typeface="Aptos"/>
               </a:rPr>
@@ -13797,7 +13797,7 @@
                 </a:solidFill>
                 <a:latin typeface="Aptos"/>
               </a:rPr>
-              <a:t>district • rooms • size • level • max_levels • lat • lng</a:t>
+              <a:t>district • rooms • size • level • max_levels • new-build/resale</a:t>
             </a:r>
           </a:p>
         </p:txBody>

</xml_diff>